<commit_message>
Data deck: move RAG-vs-long-context below LangChain; align README eval order
- Relocate "RAG vs long context" into the RAG-on-production section, below
  LangChain (README Chapter 3 + slides), update the agenda reference.
- Reorder README to match slides: Phase 7 (Evaluation) now precedes Chapter 2
  (advanced pipeline) — measure before pulling levers.
- Rewrite the day-2 concerns paragraph as "how to…" question bullets.
- Re-render slides.pdf / slides.pptx.

Co-Authored-By: Claude Opus 4.8 (1M context) <noreply@anthropic.com>
</commit_message>
<xml_diff>
--- a/03-data/slides.pptx
+++ b/03-data/slides.pptx
@@ -612,8 +612,8 @@
           <a:p>
             <a:r>
               <a:rPr lang="en-US" dirty="0"/>
-              <a:t>Filtering during search (tenant = X AND date &gt; Y) enforces permissions + freshness at
-retrieval, not after. FAISS flat is exact and plenty at lab scale.</a:t>
+              <a:t>The whole game: the model can only answer from what retrieval returns. Lab 1 prints this
+exact ranked list. top-k is the first dial students tune.</a:t>
             </a:r>
             <a:endParaRPr lang="en-US" dirty="0"/>
           </a:p>
@@ -656,95 +656,6 @@
 </file>
 
 <file path=ppt/notesSlides/notesSlide11.xml><?xml version="1.0" encoding="utf-8"?>
-<p:notes xmlns:a="http://schemas.openxmlformats.org/drawingml/2006/main" xmlns:r="http://schemas.openxmlformats.org/officeDocument/2006/relationships" xmlns:p="http://schemas.openxmlformats.org/presentationml/2006/main">
-  <p:cSld>
-    <p:spTree>
-      <p:nvGrpSpPr>
-        <p:cNvPr id="1" name=""/>
-        <p:cNvGrpSpPr/>
-        <p:nvPr/>
-      </p:nvGrpSpPr>
-      <p:grpSpPr>
-        <a:xfrm>
-          <a:off x="0" y="0"/>
-          <a:ext cx="0" cy="0"/>
-          <a:chOff x="0" y="0"/>
-          <a:chExt cx="0" cy="0"/>
-        </a:xfrm>
-      </p:grpSpPr>
-      <p:sp>
-        <p:nvSpPr>
-          <p:cNvPr id="2" name="Slide Image Placeholder 1"/>
-          <p:cNvSpPr>
-            <a:spLocks noGrp="1" noRot="1" noChangeAspect="1"/>
-          </p:cNvSpPr>
-          <p:nvPr>
-            <p:ph type="sldImg"/>
-          </p:nvPr>
-        </p:nvSpPr>
-        <p:spPr/>
-      </p:sp>
-      <p:sp>
-        <p:nvSpPr>
-          <p:cNvPr id="3" name="Notes Placeholder 2"/>
-          <p:cNvSpPr>
-            <a:spLocks noGrp="1"/>
-          </p:cNvSpPr>
-          <p:nvPr>
-            <p:ph type="body" idx="1"/>
-          </p:nvPr>
-        </p:nvSpPr>
-        <p:spPr/>
-        <p:txBody>
-          <a:bodyPr/>
-          <a:lstStyle/>
-          <a:p>
-            <a:r>
-              <a:rPr lang="en-US" dirty="0"/>
-              <a:t>The whole game: the model can only answer from what retrieval returns. Lab 1 prints this
-exact ranked list. top-k is the first dial students tune.</a:t>
-            </a:r>
-            <a:endParaRPr lang="en-US" dirty="0"/>
-          </a:p>
-        </p:txBody>
-      </p:sp>
-      <p:sp>
-        <p:nvSpPr>
-          <p:cNvPr id="4" name="Slide Number Placeholder 3"/>
-          <p:cNvSpPr>
-            <a:spLocks noGrp="1"/>
-          </p:cNvSpPr>
-          <p:nvPr>
-            <p:ph type="sldNum" sz="quarter" idx="10"/>
-          </p:nvPr>
-        </p:nvSpPr>
-        <p:spPr/>
-        <p:txBody>
-          <a:bodyPr/>
-          <a:lstStyle/>
-          <a:p>
-            <a:fld id="{F7021451-1387-4CA6-816F-3879F97B5CBC}" type="slidenum">
-              <a:rPr lang="en-US"/>
-              <a:t>11</a:t>
-            </a:fld>
-            <a:endParaRPr lang="en-US"/>
-          </a:p>
-        </p:txBody>
-      </p:sp>
-    </p:spTree>
-    <p:extLst>
-      <p:ext uri="{BB962C8B-B14F-4D97-AF65-F5344CB8AC3E}">
-        <p14:creationId xmlns:p14="http://schemas.microsoft.com/office/powerpoint/2010/main" val="1024086991"/>
-      </p:ext>
-    </p:extLst>
-  </p:cSld>
-  <p:clrMapOvr>
-    <a:masterClrMapping/>
-  </p:clrMapOvr>
-</p:notes>
-</file>
-
-<file path=ppt/notesSlides/notesSlide12.xml><?xml version="1.0" encoding="utf-8"?>
 <p:notes xmlns:a="http://schemas.openxmlformats.org/drawingml/2006/main" xmlns:r="http://schemas.openxmlformats.org/officeDocument/2006/relationships" xmlns:p="http://schemas.openxmlformats.org/presentationml/2006/main">
   <p:cSld>
     <p:spTree>
@@ -814,7 +725,7 @@
           <a:p>
             <a:fld id="{F7021451-1387-4CA6-816F-3879F97B5CBC}" type="slidenum">
               <a:rPr lang="en-US"/>
-              <a:t>12</a:t>
+              <a:t>11</a:t>
             </a:fld>
             <a:endParaRPr lang="en-US"/>
           </a:p>
@@ -833,7 +744,7 @@
 </p:notes>
 </file>
 
-<file path=ppt/notesSlides/notesSlide13.xml><?xml version="1.0" encoding="utf-8"?>
+<file path=ppt/notesSlides/notesSlide12.xml><?xml version="1.0" encoding="utf-8"?>
 <p:notes xmlns:a="http://schemas.openxmlformats.org/drawingml/2006/main" xmlns:r="http://schemas.openxmlformats.org/officeDocument/2006/relationships" xmlns:p="http://schemas.openxmlformats.org/presentationml/2006/main">
   <p:cSld>
     <p:spTree>
@@ -904,7 +815,7 @@
           <a:p>
             <a:fld id="{F7021451-1387-4CA6-816F-3879F97B5CBC}" type="slidenum">
               <a:rPr lang="en-US"/>
-              <a:t>13</a:t>
+              <a:t>12</a:t>
             </a:fld>
             <a:endParaRPr lang="en-US"/>
           </a:p>
@@ -923,7 +834,7 @@
 </p:notes>
 </file>
 
-<file path=ppt/notesSlides/notesSlide14.xml><?xml version="1.0" encoding="utf-8"?>
+<file path=ppt/notesSlides/notesSlide13.xml><?xml version="1.0" encoding="utf-8"?>
 <p:notes xmlns:a="http://schemas.openxmlformats.org/drawingml/2006/main" xmlns:r="http://schemas.openxmlformats.org/officeDocument/2006/relationships" xmlns:p="http://schemas.openxmlformats.org/presentationml/2006/main">
   <p:cSld>
     <p:spTree>
@@ -994,7 +905,7 @@
           <a:p>
             <a:fld id="{F7021451-1387-4CA6-816F-3879F97B5CBC}" type="slidenum">
               <a:rPr lang="en-US"/>
-              <a:t>14</a:t>
+              <a:t>13</a:t>
             </a:fld>
             <a:endParaRPr lang="en-US"/>
           </a:p>
@@ -1013,7 +924,7 @@
 </p:notes>
 </file>
 
-<file path=ppt/notesSlides/notesSlide15.xml><?xml version="1.0" encoding="utf-8"?>
+<file path=ppt/notesSlides/notesSlide14.xml><?xml version="1.0" encoding="utf-8"?>
 <p:notes xmlns:a="http://schemas.openxmlformats.org/drawingml/2006/main" xmlns:r="http://schemas.openxmlformats.org/officeDocument/2006/relationships" xmlns:p="http://schemas.openxmlformats.org/presentationml/2006/main">
   <p:cSld>
     <p:spTree>
@@ -1083,7 +994,7 @@
           <a:p>
             <a:fld id="{F7021451-1387-4CA6-816F-3879F97B5CBC}" type="slidenum">
               <a:rPr lang="en-US"/>
-              <a:t>15</a:t>
+              <a:t>14</a:t>
             </a:fld>
             <a:endParaRPr lang="en-US"/>
           </a:p>
@@ -1102,7 +1013,7 @@
 </p:notes>
 </file>
 
-<file path=ppt/notesSlides/notesSlide16.xml><?xml version="1.0" encoding="utf-8"?>
+<file path=ppt/notesSlides/notesSlide15.xml><?xml version="1.0" encoding="utf-8"?>
 <p:notes xmlns:a="http://schemas.openxmlformats.org/drawingml/2006/main" xmlns:r="http://schemas.openxmlformats.org/officeDocument/2006/relationships" xmlns:p="http://schemas.openxmlformats.org/presentationml/2006/main">
   <p:cSld>
     <p:spTree>
@@ -1172,7 +1083,7 @@
           <a:p>
             <a:fld id="{F7021451-1387-4CA6-816F-3879F97B5CBC}" type="slidenum">
               <a:rPr lang="en-US"/>
-              <a:t>16</a:t>
+              <a:t>15</a:t>
             </a:fld>
             <a:endParaRPr lang="en-US"/>
           </a:p>
@@ -1191,7 +1102,7 @@
 </p:notes>
 </file>
 
-<file path=ppt/notesSlides/notesSlide17.xml><?xml version="1.0" encoding="utf-8"?>
+<file path=ppt/notesSlides/notesSlide16.xml><?xml version="1.0" encoding="utf-8"?>
 <p:notes xmlns:a="http://schemas.openxmlformats.org/drawingml/2006/main" xmlns:r="http://schemas.openxmlformats.org/officeDocument/2006/relationships" xmlns:p="http://schemas.openxmlformats.org/presentationml/2006/main">
   <p:cSld>
     <p:spTree>
@@ -1261,7 +1172,7 @@
           <a:p>
             <a:fld id="{F7021451-1387-4CA6-816F-3879F97B5CBC}" type="slidenum">
               <a:rPr lang="en-US"/>
-              <a:t>17</a:t>
+              <a:t>16</a:t>
             </a:fld>
             <a:endParaRPr lang="en-US"/>
           </a:p>
@@ -1280,7 +1191,7 @@
 </p:notes>
 </file>
 
-<file path=ppt/notesSlides/notesSlide18.xml><?xml version="1.0" encoding="utf-8"?>
+<file path=ppt/notesSlides/notesSlide17.xml><?xml version="1.0" encoding="utf-8"?>
 <p:notes xmlns:a="http://schemas.openxmlformats.org/drawingml/2006/main" xmlns:r="http://schemas.openxmlformats.org/officeDocument/2006/relationships" xmlns:p="http://schemas.openxmlformats.org/presentationml/2006/main">
   <p:cSld>
     <p:spTree>
@@ -1328,6 +1239,97 @@
               <a:rPr lang="en-US" dirty="0"/>
               <a:t>Learn the phases by hand and LangChain is just learning which method wraps each. There's
 no "submit a job to their cloud" — running on managed infra is a deploy step, not the chain.</a:t>
+            </a:r>
+            <a:endParaRPr lang="en-US" dirty="0"/>
+          </a:p>
+        </p:txBody>
+      </p:sp>
+      <p:sp>
+        <p:nvSpPr>
+          <p:cNvPr id="4" name="Slide Number Placeholder 3"/>
+          <p:cNvSpPr>
+            <a:spLocks noGrp="1"/>
+          </p:cNvSpPr>
+          <p:nvPr>
+            <p:ph type="sldNum" sz="quarter" idx="10"/>
+          </p:nvPr>
+        </p:nvSpPr>
+        <p:spPr/>
+        <p:txBody>
+          <a:bodyPr/>
+          <a:lstStyle/>
+          <a:p>
+            <a:fld id="{F7021451-1387-4CA6-816F-3879F97B5CBC}" type="slidenum">
+              <a:rPr lang="en-US"/>
+              <a:t>17</a:t>
+            </a:fld>
+            <a:endParaRPr lang="en-US"/>
+          </a:p>
+        </p:txBody>
+      </p:sp>
+    </p:spTree>
+    <p:extLst>
+      <p:ext uri="{BB962C8B-B14F-4D97-AF65-F5344CB8AC3E}">
+        <p14:creationId xmlns:p14="http://schemas.microsoft.com/office/powerpoint/2010/main" val="1024086991"/>
+      </p:ext>
+    </p:extLst>
+  </p:cSld>
+  <p:clrMapOvr>
+    <a:masterClrMapping/>
+  </p:clrMapOvr>
+</p:notes>
+</file>
+
+<file path=ppt/notesSlides/notesSlide18.xml><?xml version="1.0" encoding="utf-8"?>
+<p:notes xmlns:a="http://schemas.openxmlformats.org/drawingml/2006/main" xmlns:r="http://schemas.openxmlformats.org/officeDocument/2006/relationships" xmlns:p="http://schemas.openxmlformats.org/presentationml/2006/main">
+  <p:cSld>
+    <p:spTree>
+      <p:nvGrpSpPr>
+        <p:cNvPr id="1" name=""/>
+        <p:cNvGrpSpPr/>
+        <p:nvPr/>
+      </p:nvGrpSpPr>
+      <p:grpSpPr>
+        <a:xfrm>
+          <a:off x="0" y="0"/>
+          <a:ext cx="0" cy="0"/>
+          <a:chOff x="0" y="0"/>
+          <a:chExt cx="0" cy="0"/>
+        </a:xfrm>
+      </p:grpSpPr>
+      <p:sp>
+        <p:nvSpPr>
+          <p:cNvPr id="2" name="Slide Image Placeholder 1"/>
+          <p:cNvSpPr>
+            <a:spLocks noGrp="1" noRot="1" noChangeAspect="1"/>
+          </p:cNvSpPr>
+          <p:nvPr>
+            <p:ph type="sldImg"/>
+          </p:nvPr>
+        </p:nvSpPr>
+        <p:spPr/>
+      </p:sp>
+      <p:sp>
+        <p:nvSpPr>
+          <p:cNvPr id="3" name="Notes Placeholder 2"/>
+          <p:cNvSpPr>
+            <a:spLocks noGrp="1"/>
+          </p:cNvSpPr>
+          <p:nvPr>
+            <p:ph type="body" idx="1"/>
+          </p:nvPr>
+        </p:nvSpPr>
+        <p:spPr/>
+        <p:txBody>
+          <a:bodyPr/>
+          <a:lstStyle/>
+          <a:p>
+            <a:r>
+              <a:rPr lang="en-US" dirty="0"/>
+              <a:t>With the pipeline built and productized, the honest question: why retrieve at all, rather
+than dump everything in the window? Not either/or — prompt caching offsets long context for
+*static* data, but a *dynamic* corpus pays the full token tax every request. Long context can
+reason over the *gap between* documents; RAG only sees isolated snippets.</a:t>
             </a:r>
             <a:endParaRPr lang="en-US" dirty="0"/>
           </a:p>
@@ -1952,10 +1954,9 @@
           <a:p>
             <a:r>
               <a:rPr lang="en-US" dirty="0"/>
-              <a:t>Why retrieve at all, rather than dump everything in the window? This motivates the pipeline
-that follows. Not either/or — prompt caching offsets long context for *static* data, but a
-*dynamic* corpus pays the full token tax every request. Long context can reason over the
-*gap between* documents; RAG only sees isolated snippets.</a:t>
+              <a:t>The whole layer on one slide. One shared vector store: INDEX writes it once; ANSWER reads
+top-k from it per query. Note the same embedder feeds both sides — the #1 RAG rule. Walk
+left-to-right on each lane.</a:t>
             </a:r>
             <a:endParaRPr lang="en-US" dirty="0"/>
           </a:p>
@@ -1998,96 +1999,6 @@
 </file>
 
 <file path=ppt/notesSlides/notesSlide6.xml><?xml version="1.0" encoding="utf-8"?>
-<p:notes xmlns:a="http://schemas.openxmlformats.org/drawingml/2006/main" xmlns:r="http://schemas.openxmlformats.org/officeDocument/2006/relationships" xmlns:p="http://schemas.openxmlformats.org/presentationml/2006/main">
-  <p:cSld>
-    <p:spTree>
-      <p:nvGrpSpPr>
-        <p:cNvPr id="1" name=""/>
-        <p:cNvGrpSpPr/>
-        <p:nvPr/>
-      </p:nvGrpSpPr>
-      <p:grpSpPr>
-        <a:xfrm>
-          <a:off x="0" y="0"/>
-          <a:ext cx="0" cy="0"/>
-          <a:chOff x="0" y="0"/>
-          <a:chExt cx="0" cy="0"/>
-        </a:xfrm>
-      </p:grpSpPr>
-      <p:sp>
-        <p:nvSpPr>
-          <p:cNvPr id="2" name="Slide Image Placeholder 1"/>
-          <p:cNvSpPr>
-            <a:spLocks noGrp="1" noRot="1" noChangeAspect="1"/>
-          </p:cNvSpPr>
-          <p:nvPr>
-            <p:ph type="sldImg"/>
-          </p:nvPr>
-        </p:nvSpPr>
-        <p:spPr/>
-      </p:sp>
-      <p:sp>
-        <p:nvSpPr>
-          <p:cNvPr id="3" name="Notes Placeholder 2"/>
-          <p:cNvSpPr>
-            <a:spLocks noGrp="1"/>
-          </p:cNvSpPr>
-          <p:nvPr>
-            <p:ph type="body" idx="1"/>
-          </p:nvPr>
-        </p:nvSpPr>
-        <p:spPr/>
-        <p:txBody>
-          <a:bodyPr/>
-          <a:lstStyle/>
-          <a:p>
-            <a:r>
-              <a:rPr lang="en-US" dirty="0"/>
-              <a:t>The whole layer on one slide. One shared vector store: INDEX writes it once; ANSWER reads
-top-k from it per query. Note the same embedder feeds both sides — the #1 RAG rule. Walk
-left-to-right on each lane.</a:t>
-            </a:r>
-            <a:endParaRPr lang="en-US" dirty="0"/>
-          </a:p>
-        </p:txBody>
-      </p:sp>
-      <p:sp>
-        <p:nvSpPr>
-          <p:cNvPr id="4" name="Slide Number Placeholder 3"/>
-          <p:cNvSpPr>
-            <a:spLocks noGrp="1"/>
-          </p:cNvSpPr>
-          <p:nvPr>
-            <p:ph type="sldNum" sz="quarter" idx="10"/>
-          </p:nvPr>
-        </p:nvSpPr>
-        <p:spPr/>
-        <p:txBody>
-          <a:bodyPr/>
-          <a:lstStyle/>
-          <a:p>
-            <a:fld id="{F7021451-1387-4CA6-816F-3879F97B5CBC}" type="slidenum">
-              <a:rPr lang="en-US"/>
-              <a:t>6</a:t>
-            </a:fld>
-            <a:endParaRPr lang="en-US"/>
-          </a:p>
-        </p:txBody>
-      </p:sp>
-    </p:spTree>
-    <p:extLst>
-      <p:ext uri="{BB962C8B-B14F-4D97-AF65-F5344CB8AC3E}">
-        <p14:creationId xmlns:p14="http://schemas.microsoft.com/office/powerpoint/2010/main" val="1024086991"/>
-      </p:ext>
-    </p:extLst>
-  </p:cSld>
-  <p:clrMapOvr>
-    <a:masterClrMapping/>
-  </p:clrMapOvr>
-</p:notes>
-</file>
-
-<file path=ppt/notesSlides/notesSlide7.xml><?xml version="1.0" encoding="utf-8"?>
 <p:notes xmlns:a="http://schemas.openxmlformats.org/drawingml/2006/main" xmlns:r="http://schemas.openxmlformats.org/officeDocument/2006/relationships" xmlns:p="http://schemas.openxmlformats.org/presentationml/2006/main">
   <p:cSld>
     <p:spTree>
@@ -2157,7 +2068,7 @@
           <a:p>
             <a:fld id="{F7021451-1387-4CA6-816F-3879F97B5CBC}" type="slidenum">
               <a:rPr lang="en-US"/>
-              <a:t>7</a:t>
+              <a:t>6</a:t>
             </a:fld>
             <a:endParaRPr lang="en-US"/>
           </a:p>
@@ -2176,7 +2087,7 @@
 </p:notes>
 </file>
 
-<file path=ppt/notesSlides/notesSlide8.xml><?xml version="1.0" encoding="utf-8"?>
+<file path=ppt/notesSlides/notesSlide7.xml><?xml version="1.0" encoding="utf-8"?>
 <p:notes xmlns:a="http://schemas.openxmlformats.org/drawingml/2006/main" xmlns:r="http://schemas.openxmlformats.org/officeDocument/2006/relationships" xmlns:p="http://schemas.openxmlformats.org/presentationml/2006/main">
   <p:cSld>
     <p:spTree>
@@ -2246,7 +2157,7 @@
           <a:p>
             <a:fld id="{F7021451-1387-4CA6-816F-3879F97B5CBC}" type="slidenum">
               <a:rPr lang="en-US"/>
-              <a:t>8</a:t>
+              <a:t>7</a:t>
             </a:fld>
             <a:endParaRPr lang="en-US"/>
           </a:p>
@@ -2265,7 +2176,7 @@
 </p:notes>
 </file>
 
-<file path=ppt/notesSlides/notesSlide9.xml><?xml version="1.0" encoding="utf-8"?>
+<file path=ppt/notesSlides/notesSlide8.xml><?xml version="1.0" encoding="utf-8"?>
 <p:notes xmlns:a="http://schemas.openxmlformats.org/drawingml/2006/main" xmlns:r="http://schemas.openxmlformats.org/officeDocument/2006/relationships" xmlns:p="http://schemas.openxmlformats.org/presentationml/2006/main">
   <p:cSld>
     <p:spTree>
@@ -2313,6 +2224,95 @@
               <a:rPr lang="en-US" dirty="0"/>
               <a:t>The embedder is its own small model, separate from the LLM (CPU or a sliver of GPU).
 Two models = incomparable spaces, "near" becomes meaningless. Our labs use bge-small.</a:t>
+            </a:r>
+            <a:endParaRPr lang="en-US" dirty="0"/>
+          </a:p>
+        </p:txBody>
+      </p:sp>
+      <p:sp>
+        <p:nvSpPr>
+          <p:cNvPr id="4" name="Slide Number Placeholder 3"/>
+          <p:cNvSpPr>
+            <a:spLocks noGrp="1"/>
+          </p:cNvSpPr>
+          <p:nvPr>
+            <p:ph type="sldNum" sz="quarter" idx="10"/>
+          </p:nvPr>
+        </p:nvSpPr>
+        <p:spPr/>
+        <p:txBody>
+          <a:bodyPr/>
+          <a:lstStyle/>
+          <a:p>
+            <a:fld id="{F7021451-1387-4CA6-816F-3879F97B5CBC}" type="slidenum">
+              <a:rPr lang="en-US"/>
+              <a:t>8</a:t>
+            </a:fld>
+            <a:endParaRPr lang="en-US"/>
+          </a:p>
+        </p:txBody>
+      </p:sp>
+    </p:spTree>
+    <p:extLst>
+      <p:ext uri="{BB962C8B-B14F-4D97-AF65-F5344CB8AC3E}">
+        <p14:creationId xmlns:p14="http://schemas.microsoft.com/office/powerpoint/2010/main" val="1024086991"/>
+      </p:ext>
+    </p:extLst>
+  </p:cSld>
+  <p:clrMapOvr>
+    <a:masterClrMapping/>
+  </p:clrMapOvr>
+</p:notes>
+</file>
+
+<file path=ppt/notesSlides/notesSlide9.xml><?xml version="1.0" encoding="utf-8"?>
+<p:notes xmlns:a="http://schemas.openxmlformats.org/drawingml/2006/main" xmlns:r="http://schemas.openxmlformats.org/officeDocument/2006/relationships" xmlns:p="http://schemas.openxmlformats.org/presentationml/2006/main">
+  <p:cSld>
+    <p:spTree>
+      <p:nvGrpSpPr>
+        <p:cNvPr id="1" name=""/>
+        <p:cNvGrpSpPr/>
+        <p:nvPr/>
+      </p:nvGrpSpPr>
+      <p:grpSpPr>
+        <a:xfrm>
+          <a:off x="0" y="0"/>
+          <a:ext cx="0" cy="0"/>
+          <a:chOff x="0" y="0"/>
+          <a:chExt cx="0" cy="0"/>
+        </a:xfrm>
+      </p:grpSpPr>
+      <p:sp>
+        <p:nvSpPr>
+          <p:cNvPr id="2" name="Slide Image Placeholder 1"/>
+          <p:cNvSpPr>
+            <a:spLocks noGrp="1" noRot="1" noChangeAspect="1"/>
+          </p:cNvSpPr>
+          <p:nvPr>
+            <p:ph type="sldImg"/>
+          </p:nvPr>
+        </p:nvSpPr>
+        <p:spPr/>
+      </p:sp>
+      <p:sp>
+        <p:nvSpPr>
+          <p:cNvPr id="3" name="Notes Placeholder 2"/>
+          <p:cNvSpPr>
+            <a:spLocks noGrp="1"/>
+          </p:cNvSpPr>
+          <p:nvPr>
+            <p:ph type="body" idx="1"/>
+          </p:nvPr>
+        </p:nvSpPr>
+        <p:spPr/>
+        <p:txBody>
+          <a:bodyPr/>
+          <a:lstStyle/>
+          <a:p>
+            <a:r>
+              <a:rPr lang="en-US" dirty="0"/>
+              <a:t>Filtering during search (tenant = X AND date &gt; Y) enforces permissions + freshness at
+retrieval, not after. FAISS flat is exact and plenty at lab scale.</a:t>
             </a:r>
             <a:endParaRPr lang="en-US" dirty="0"/>
           </a:p>

</xml_diff>